<commit_message>
lesson 16 added useEffect with fetch API
</commit_message>
<xml_diff>
--- a/PPT/Day-15-Slide-Deck.pptx
+++ b/PPT/Day-15-Slide-Deck.pptx
@@ -5,7 +5,7 @@
     <p:sldMasterId id="2147483660" r:id="rId1"/>
   </p:sldMasterIdLst>
   <p:notesMasterIdLst>
-    <p:notesMasterId r:id="rId34"/>
+    <p:notesMasterId r:id="rId35"/>
   </p:notesMasterIdLst>
   <p:sldIdLst>
     <p:sldId id="256" r:id="rId2"/>
@@ -27,19 +27,20 @@
     <p:sldId id="339" r:id="rId18"/>
     <p:sldId id="340" r:id="rId19"/>
     <p:sldId id="341" r:id="rId20"/>
-    <p:sldId id="344" r:id="rId21"/>
-    <p:sldId id="345" r:id="rId22"/>
-    <p:sldId id="350" r:id="rId23"/>
-    <p:sldId id="351" r:id="rId24"/>
-    <p:sldId id="355" r:id="rId25"/>
-    <p:sldId id="356" r:id="rId26"/>
-    <p:sldId id="295" r:id="rId27"/>
-    <p:sldId id="346" r:id="rId28"/>
-    <p:sldId id="347" r:id="rId29"/>
-    <p:sldId id="352" r:id="rId30"/>
-    <p:sldId id="353" r:id="rId31"/>
-    <p:sldId id="258" r:id="rId32"/>
-    <p:sldId id="281" r:id="rId33"/>
+    <p:sldId id="360" r:id="rId21"/>
+    <p:sldId id="344" r:id="rId22"/>
+    <p:sldId id="345" r:id="rId23"/>
+    <p:sldId id="350" r:id="rId24"/>
+    <p:sldId id="351" r:id="rId25"/>
+    <p:sldId id="355" r:id="rId26"/>
+    <p:sldId id="356" r:id="rId27"/>
+    <p:sldId id="295" r:id="rId28"/>
+    <p:sldId id="346" r:id="rId29"/>
+    <p:sldId id="347" r:id="rId30"/>
+    <p:sldId id="352" r:id="rId31"/>
+    <p:sldId id="353" r:id="rId32"/>
+    <p:sldId id="258" r:id="rId33"/>
+    <p:sldId id="281" r:id="rId34"/>
   </p:sldIdLst>
   <p:sldSz cx="12192000" cy="6858000"/>
   <p:notesSz cx="6858000" cy="9144000"/>
@@ -228,7 +229,7 @@
           <a:p>
             <a:fld id="{B83411B5-A9B8-6D4E-A83B-91456309AD37}" type="datetimeFigureOut">
               <a:rPr lang="en-US" smtClean="0"/>
-              <a:t>2/28/26</a:t>
+              <a:t>3/10/2026</a:t>
             </a:fld>
             <a:endParaRPr lang="en-US"/>
           </a:p>
@@ -692,7 +693,7 @@
           <a:p>
             <a:fld id="{CFE641A9-FDE3-4583-B812-65C4064188F6}" type="slidenum">
               <a:rPr lang="en-CA" smtClean="0"/>
-              <a:t>22</a:t>
+              <a:t>23</a:t>
             </a:fld>
             <a:endParaRPr lang="en-CA"/>
           </a:p>
@@ -800,7 +801,7 @@
           <a:p>
             <a:fld id="{CFE641A9-FDE3-4583-B812-65C4064188F6}" type="slidenum">
               <a:rPr lang="en-CA" smtClean="0"/>
-              <a:t>24</a:t>
+              <a:t>25</a:t>
             </a:fld>
             <a:endParaRPr lang="en-CA"/>
           </a:p>
@@ -908,7 +909,7 @@
           <a:p>
             <a:fld id="{CFE641A9-FDE3-4583-B812-65C4064188F6}" type="slidenum">
               <a:rPr lang="en-CA" smtClean="0"/>
-              <a:t>26</a:t>
+              <a:t>27</a:t>
             </a:fld>
             <a:endParaRPr lang="en-CA"/>
           </a:p>
@@ -1016,7 +1017,7 @@
           <a:p>
             <a:fld id="{CFE641A9-FDE3-4583-B812-65C4064188F6}" type="slidenum">
               <a:rPr lang="en-CA" smtClean="0"/>
-              <a:t>27</a:t>
+              <a:t>28</a:t>
             </a:fld>
             <a:endParaRPr lang="en-CA"/>
           </a:p>
@@ -1124,7 +1125,7 @@
           <a:p>
             <a:fld id="{CFE641A9-FDE3-4583-B812-65C4064188F6}" type="slidenum">
               <a:rPr lang="en-CA" smtClean="0"/>
-              <a:t>29</a:t>
+              <a:t>30</a:t>
             </a:fld>
             <a:endParaRPr lang="en-CA"/>
           </a:p>
@@ -1208,7 +1209,7 @@
           <a:p>
             <a:fld id="{CFE641A9-FDE3-4583-B812-65C4064188F6}" type="slidenum">
               <a:rPr lang="en-CA" smtClean="0"/>
-              <a:t>32</a:t>
+              <a:t>33</a:t>
             </a:fld>
             <a:endParaRPr lang="en-CA"/>
           </a:p>
@@ -2072,7 +2073,7 @@
           <a:p>
             <a:fld id="{CFE641A9-FDE3-4583-B812-65C4064188F6}" type="slidenum">
               <a:rPr lang="en-CA" smtClean="0"/>
-              <a:t>20</a:t>
+              <a:t>21</a:t>
             </a:fld>
             <a:endParaRPr lang="en-CA"/>
           </a:p>
@@ -3118,7 +3119,7 @@
           <a:p>
             <a:fld id="{42324503-65B2-B147-B7D0-901C284D8BB3}" type="datetimeFigureOut">
               <a:rPr lang="en-US" smtClean="0"/>
-              <a:t>2/28/26</a:t>
+              <a:t>3/10/2026</a:t>
             </a:fld>
             <a:endParaRPr lang="en-US"/>
           </a:p>
@@ -4183,13 +4184,13 @@
         </p:nvSpPr>
         <p:spPr>
           <a:xfrm>
-            <a:off x="838200" y="1187669"/>
-            <a:ext cx="10515600" cy="4324857"/>
+            <a:off x="130050" y="1187669"/>
+            <a:ext cx="7191500" cy="4324857"/>
           </a:xfrm>
         </p:spPr>
         <p:txBody>
           <a:bodyPr>
-            <a:normAutofit fontScale="62500" lnSpcReduction="20000"/>
+            <a:normAutofit fontScale="55000" lnSpcReduction="20000"/>
           </a:bodyPr>
           <a:lstStyle/>
           <a:p>
@@ -4220,9 +4221,24 @@
                 <a:latin typeface="Consolas" panose="020B0609020204030204" pitchFamily="49" charset="0"/>
                 <a:cs typeface="Consolas" panose="020B0609020204030204" pitchFamily="49" charset="0"/>
               </a:rPr>
-              <a:t>useEffect</a:t>
-            </a:r>
-            <a:endParaRPr lang="en-US" dirty="0"/>
+              <a:t>useEffect:</a:t>
+            </a:r>
+            <a:r>
+              <a:rPr lang="en-US" dirty="0" err="1"/>
+              <a:t>used</a:t>
+            </a:r>
+            <a:r>
+              <a:rPr lang="en-US" dirty="0"/>
+              <a:t> to </a:t>
+            </a:r>
+            <a:r>
+              <a:rPr lang="en-US" b="1" dirty="0"/>
+              <a:t>run code after a component renders (updates the page)</a:t>
+            </a:r>
+            <a:r>
+              <a:rPr lang="en-US" dirty="0"/>
+              <a:t>.</a:t>
+            </a:r>
           </a:p>
           <a:p>
             <a:r>
@@ -4230,9 +4246,24 @@
                 <a:latin typeface="Consolas" panose="020B0609020204030204" pitchFamily="49" charset="0"/>
                 <a:cs typeface="Consolas" panose="020B0609020204030204" pitchFamily="49" charset="0"/>
               </a:rPr>
-              <a:t>useRef</a:t>
-            </a:r>
-            <a:endParaRPr lang="en-US" dirty="0"/>
+              <a:t>useRef:</a:t>
+            </a:r>
+            <a:r>
+              <a:rPr lang="en-US" dirty="0" err="1"/>
+              <a:t>used</a:t>
+            </a:r>
+            <a:r>
+              <a:rPr lang="en-US" dirty="0"/>
+              <a:t> to </a:t>
+            </a:r>
+            <a:r>
+              <a:rPr lang="en-US" b="1" dirty="0"/>
+              <a:t>store a value that persists between renders without causing re-render</a:t>
+            </a:r>
+            <a:r>
+              <a:rPr lang="en-US" dirty="0"/>
+              <a:t>.</a:t>
+            </a:r>
           </a:p>
           <a:p>
             <a:r>
@@ -4286,6 +4317,211 @@
               <a:rPr lang="en-US" dirty="0"/>
               <a:t>Encapsulate reusable logic</a:t>
             </a:r>
+          </a:p>
+        </p:txBody>
+      </p:sp>
+      <p:sp>
+        <p:nvSpPr>
+          <p:cNvPr id="5" name="Rectangle 3">
+            <a:extLst>
+              <a:ext uri="{FF2B5EF4-FFF2-40B4-BE49-F238E27FC236}">
+                <a16:creationId xmlns:a16="http://schemas.microsoft.com/office/drawing/2014/main" id="{92A7654A-3268-A829-FB38-22DEFCEB81C2}"/>
+              </a:ext>
+            </a:extLst>
+          </p:cNvPr>
+          <p:cNvSpPr>
+            <a:spLocks noChangeArrowheads="1"/>
+          </p:cNvSpPr>
+          <p:nvPr/>
+        </p:nvSpPr>
+        <p:spPr bwMode="auto">
+          <a:xfrm>
+            <a:off x="7613650" y="1327488"/>
+            <a:ext cx="4010150" cy="2031325"/>
+          </a:xfrm>
+          <a:prstGeom prst="rect">
+            <a:avLst/>
+          </a:prstGeom>
+          <a:noFill/>
+          <a:ln>
+            <a:noFill/>
+          </a:ln>
+          <a:effectLst/>
+          <a:extLst>
+            <a:ext uri="{909E8E84-426E-40DD-AFC4-6F175D3DCCD1}">
+              <a14:hiddenFill xmlns:a14="http://schemas.microsoft.com/office/drawing/2010/main">
+                <a:solidFill>
+                  <a:schemeClr val="accent1"/>
+                </a:solidFill>
+              </a14:hiddenFill>
+            </a:ext>
+            <a:ext uri="{91240B29-F687-4F45-9708-019B960494DF}">
+              <a14:hiddenLine xmlns:a14="http://schemas.microsoft.com/office/drawing/2010/main" w="9525">
+                <a:solidFill>
+                  <a:schemeClr val="tx1"/>
+                </a:solidFill>
+                <a:miter lim="800000"/>
+                <a:headEnd/>
+                <a:tailEnd/>
+              </a14:hiddenLine>
+            </a:ext>
+            <a:ext uri="{AF507438-7753-43E0-B8FC-AC1667EBCBE1}">
+              <a14:hiddenEffects xmlns:a14="http://schemas.microsoft.com/office/drawing/2010/main">
+                <a:effectLst>
+                  <a:outerShdw dist="35921" dir="2700000" algn="ctr" rotWithShape="0">
+                    <a:schemeClr val="bg2"/>
+                  </a:outerShdw>
+                </a:effectLst>
+              </a14:hiddenEffects>
+            </a:ext>
+          </a:extLst>
+        </p:spPr>
+        <p:txBody>
+          <a:bodyPr vert="horz" wrap="square" lIns="91440" tIns="45720" rIns="91440" bIns="45720" numCol="1" anchor="ctr" anchorCtr="0" compatLnSpc="1">
+            <a:prstTxWarp prst="textNoShape">
+              <a:avLst/>
+            </a:prstTxWarp>
+            <a:spAutoFit/>
+          </a:bodyPr>
+          <a:lstStyle/>
+          <a:p>
+            <a:pPr lvl="0" defTabSz="914400" eaLnBrk="0" fontAlgn="base" hangingPunct="0">
+              <a:spcBef>
+                <a:spcPct val="0"/>
+              </a:spcBef>
+              <a:spcAft>
+                <a:spcPct val="0"/>
+              </a:spcAft>
+              <a:buFontTx/>
+              <a:buChar char="•"/>
+            </a:pPr>
+            <a:r>
+              <a:rPr lang="en-US" altLang="en-US" dirty="0">
+                <a:latin typeface="Arial" panose="020B0604020202020204" pitchFamily="34" charset="0"/>
+              </a:rPr>
+              <a:t>Fetching data from an API</a:t>
+            </a:r>
+          </a:p>
+          <a:p>
+            <a:pPr lvl="0" defTabSz="914400" eaLnBrk="0" fontAlgn="base" hangingPunct="0">
+              <a:spcBef>
+                <a:spcPct val="0"/>
+              </a:spcBef>
+              <a:spcAft>
+                <a:spcPct val="0"/>
+              </a:spcAft>
+              <a:buFontTx/>
+              <a:buChar char="•"/>
+            </a:pPr>
+            <a:r>
+              <a:rPr lang="en-US" altLang="en-US" dirty="0">
+                <a:latin typeface="Arial" panose="020B0604020202020204" pitchFamily="34" charset="0"/>
+              </a:rPr>
+              <a:t>Updating the DOM</a:t>
+            </a:r>
+          </a:p>
+          <a:p>
+            <a:pPr lvl="0" defTabSz="914400" eaLnBrk="0" fontAlgn="base" hangingPunct="0">
+              <a:spcBef>
+                <a:spcPct val="0"/>
+              </a:spcBef>
+              <a:spcAft>
+                <a:spcPct val="0"/>
+              </a:spcAft>
+              <a:buFontTx/>
+              <a:buChar char="•"/>
+            </a:pPr>
+            <a:r>
+              <a:rPr lang="en-US" altLang="en-US" dirty="0">
+                <a:latin typeface="Arial" panose="020B0604020202020204" pitchFamily="34" charset="0"/>
+              </a:rPr>
+              <a:t>Setting timers</a:t>
+            </a:r>
+          </a:p>
+          <a:p>
+            <a:pPr lvl="0" defTabSz="914400" eaLnBrk="0" fontAlgn="base" hangingPunct="0">
+              <a:spcBef>
+                <a:spcPct val="0"/>
+              </a:spcBef>
+              <a:spcAft>
+                <a:spcPct val="0"/>
+              </a:spcAft>
+              <a:buFontTx/>
+              <a:buChar char="•"/>
+            </a:pPr>
+            <a:r>
+              <a:rPr lang="en-US" altLang="en-US" dirty="0">
+                <a:latin typeface="Arial" panose="020B0604020202020204" pitchFamily="34" charset="0"/>
+              </a:rPr>
+              <a:t>Saving data to </a:t>
+            </a:r>
+            <a:r>
+              <a:rPr lang="en-US" altLang="en-US" dirty="0" err="1">
+                <a:latin typeface="Arial" panose="020B0604020202020204" pitchFamily="34" charset="0"/>
+              </a:rPr>
+              <a:t>localStorage</a:t>
+            </a:r>
+            <a:r>
+              <a:rPr lang="en-US" altLang="en-US" dirty="0">
+                <a:latin typeface="Arial" panose="020B0604020202020204" pitchFamily="34" charset="0"/>
+              </a:rPr>
+              <a:t>/</a:t>
+            </a:r>
+            <a:r>
+              <a:rPr lang="en-US" altLang="en-US" dirty="0" err="1">
+                <a:latin typeface="Arial" panose="020B0604020202020204" pitchFamily="34" charset="0"/>
+              </a:rPr>
+              <a:t>sessionStorage</a:t>
+            </a:r>
+            <a:endParaRPr lang="en-US" altLang="en-US" dirty="0">
+              <a:latin typeface="Arial" panose="020B0604020202020204" pitchFamily="34" charset="0"/>
+            </a:endParaRPr>
+          </a:p>
+          <a:p>
+            <a:pPr lvl="0" defTabSz="914400" eaLnBrk="0" fontAlgn="base" hangingPunct="0">
+              <a:spcBef>
+                <a:spcPct val="0"/>
+              </a:spcBef>
+              <a:spcAft>
+                <a:spcPct val="0"/>
+              </a:spcAft>
+              <a:buFontTx/>
+              <a:buChar char="•"/>
+            </a:pPr>
+            <a:r>
+              <a:rPr lang="en-US" altLang="en-US" dirty="0">
+                <a:latin typeface="Arial" panose="020B0604020202020204" pitchFamily="34" charset="0"/>
+              </a:rPr>
+              <a:t>Subscribing to events</a:t>
+            </a:r>
+          </a:p>
+          <a:p>
+            <a:pPr marL="0" marR="0" lvl="0" indent="0" algn="l" defTabSz="914400" rtl="0" eaLnBrk="0" fontAlgn="base" latinLnBrk="0" hangingPunct="0">
+              <a:lnSpc>
+                <a:spcPct val="100000"/>
+              </a:lnSpc>
+              <a:spcBef>
+                <a:spcPct val="0"/>
+              </a:spcBef>
+              <a:spcAft>
+                <a:spcPct val="0"/>
+              </a:spcAft>
+              <a:buClrTx/>
+              <a:buSzTx/>
+              <a:buFontTx/>
+              <a:buChar char="•"/>
+              <a:tabLst/>
+            </a:pPr>
+            <a:endParaRPr kumimoji="0" lang="en-US" altLang="en-US" sz="1800" b="0" i="0" u="none" strike="noStrike" cap="none" normalizeH="0" baseline="0" dirty="0">
+              <a:ln>
+                <a:noFill/>
+              </a:ln>
+              <a:solidFill>
+                <a:schemeClr val="tx1"/>
+              </a:solidFill>
+              <a:effectLst/>
+              <a:latin typeface="Arial" panose="020B0604020202020204" pitchFamily="34" charset="0"/>
+            </a:endParaRPr>
           </a:p>
         </p:txBody>
       </p:sp>
@@ -4908,6 +5144,72 @@
           </a:p>
         </p:txBody>
       </p:sp>
+      <p:sp>
+        <p:nvSpPr>
+          <p:cNvPr id="4" name="TextBox 3">
+            <a:extLst>
+              <a:ext uri="{FF2B5EF4-FFF2-40B4-BE49-F238E27FC236}">
+                <a16:creationId xmlns:a16="http://schemas.microsoft.com/office/drawing/2014/main" id="{A85E0AAF-E49B-87FE-4201-8C7F387F48BD}"/>
+              </a:ext>
+            </a:extLst>
+          </p:cNvPr>
+          <p:cNvSpPr txBox="1"/>
+          <p:nvPr/>
+        </p:nvSpPr>
+        <p:spPr>
+          <a:xfrm>
+            <a:off x="838200" y="5481145"/>
+            <a:ext cx="6096000" cy="1200329"/>
+          </a:xfrm>
+          <a:prstGeom prst="rect">
+            <a:avLst/>
+          </a:prstGeom>
+          <a:noFill/>
+        </p:spPr>
+        <p:txBody>
+          <a:bodyPr wrap="square">
+            <a:spAutoFit/>
+          </a:bodyPr>
+          <a:lstStyle/>
+          <a:p>
+            <a:r>
+              <a:rPr lang="en-US" dirty="0"/>
+              <a:t>The </a:t>
+            </a:r>
+            <a:r>
+              <a:rPr lang="en-US" b="1" dirty="0"/>
+              <a:t>main benefit of a custom hook like </a:t>
+            </a:r>
+            <a:r>
+              <a:rPr lang="en-US" b="1" dirty="0" err="1">
+                <a:latin typeface="Courier New" panose="02070309020205020404" pitchFamily="49" charset="0"/>
+              </a:rPr>
+              <a:t>useToggle</a:t>
+            </a:r>
+            <a:r>
+              <a:rPr lang="en-US" dirty="0"/>
+              <a:t> is </a:t>
+            </a:r>
+            <a:r>
+              <a:rPr lang="en-US" b="1" dirty="0"/>
+              <a:t>reusability and cleaner component code</a:t>
+            </a:r>
+            <a:r>
+              <a:rPr lang="en-US" dirty="0"/>
+              <a:t>. Instead of writing the same toggle logic in many components, you </a:t>
+            </a:r>
+            <a:r>
+              <a:rPr lang="en-US" b="1" dirty="0"/>
+              <a:t>encapsulate it once and reuse it everywhere</a:t>
+            </a:r>
+            <a:r>
+              <a:rPr lang="en-US" dirty="0"/>
+              <a:t>.</a:t>
+            </a:r>
+            <a:endParaRPr lang="en-CA" dirty="0"/>
+          </a:p>
+        </p:txBody>
+      </p:sp>
     </p:spTree>
     <p:extLst>
       <p:ext uri="{BB962C8B-B14F-4D97-AF65-F5344CB8AC3E}">
@@ -5047,6 +5349,288 @@
   <p:cSld>
     <p:spTree>
       <p:nvGrpSpPr>
+        <p:cNvPr id="1" name=""/>
+        <p:cNvGrpSpPr/>
+        <p:nvPr/>
+      </p:nvGrpSpPr>
+      <p:grpSpPr>
+        <a:xfrm>
+          <a:off x="0" y="0"/>
+          <a:ext cx="0" cy="0"/>
+          <a:chOff x="0" y="0"/>
+          <a:chExt cx="0" cy="0"/>
+        </a:xfrm>
+      </p:grpSpPr>
+      <p:sp>
+        <p:nvSpPr>
+          <p:cNvPr id="2" name="Title 1">
+            <a:extLst>
+              <a:ext uri="{FF2B5EF4-FFF2-40B4-BE49-F238E27FC236}">
+                <a16:creationId xmlns:a16="http://schemas.microsoft.com/office/drawing/2014/main" id="{C843AC0E-6B6B-DED9-A9AE-49C3657BE244}"/>
+              </a:ext>
+            </a:extLst>
+          </p:cNvPr>
+          <p:cNvSpPr>
+            <a:spLocks noGrp="1"/>
+          </p:cNvSpPr>
+          <p:nvPr>
+            <p:ph type="title"/>
+          </p:nvPr>
+        </p:nvSpPr>
+        <p:spPr/>
+        <p:txBody>
+          <a:bodyPr/>
+          <a:lstStyle/>
+          <a:p>
+            <a:endParaRPr lang="en-CA"/>
+          </a:p>
+        </p:txBody>
+      </p:sp>
+      <p:sp>
+        <p:nvSpPr>
+          <p:cNvPr id="3" name="Content Placeholder 2">
+            <a:extLst>
+              <a:ext uri="{FF2B5EF4-FFF2-40B4-BE49-F238E27FC236}">
+                <a16:creationId xmlns:a16="http://schemas.microsoft.com/office/drawing/2014/main" id="{4BFDA517-5789-4F29-6B4F-E846DA64EC66}"/>
+              </a:ext>
+            </a:extLst>
+          </p:cNvPr>
+          <p:cNvSpPr>
+            <a:spLocks noGrp="1"/>
+          </p:cNvSpPr>
+          <p:nvPr>
+            <p:ph idx="1"/>
+          </p:nvPr>
+        </p:nvSpPr>
+        <p:spPr/>
+        <p:txBody>
+          <a:bodyPr/>
+          <a:lstStyle/>
+          <a:p>
+            <a:endParaRPr lang="en-CA" dirty="0"/>
+          </a:p>
+        </p:txBody>
+      </p:sp>
+      <p:sp>
+        <p:nvSpPr>
+          <p:cNvPr id="5" name="TextBox 4">
+            <a:extLst>
+              <a:ext uri="{FF2B5EF4-FFF2-40B4-BE49-F238E27FC236}">
+                <a16:creationId xmlns:a16="http://schemas.microsoft.com/office/drawing/2014/main" id="{7667F007-4D4F-8E85-7752-46C456F462F7}"/>
+              </a:ext>
+            </a:extLst>
+          </p:cNvPr>
+          <p:cNvSpPr txBox="1"/>
+          <p:nvPr/>
+        </p:nvSpPr>
+        <p:spPr>
+          <a:xfrm>
+            <a:off x="1327150" y="996950"/>
+            <a:ext cx="8680450" cy="2585323"/>
+          </a:xfrm>
+          <a:prstGeom prst="rect">
+            <a:avLst/>
+          </a:prstGeom>
+          <a:noFill/>
+        </p:spPr>
+        <p:txBody>
+          <a:bodyPr wrap="square">
+            <a:spAutoFit/>
+          </a:bodyPr>
+          <a:lstStyle/>
+          <a:p>
+            <a:pPr>
+              <a:buNone/>
+            </a:pPr>
+            <a:r>
+              <a:rPr lang="en-US" b="1" dirty="0"/>
+              <a:t>Problem Without a Custom Hook</a:t>
+            </a:r>
+          </a:p>
+          <a:p>
+            <a:pPr>
+              <a:buNone/>
+            </a:pPr>
+            <a:r>
+              <a:rPr lang="en-US" dirty="0"/>
+              <a:t>Imagine you need toggle functionality in many components.</a:t>
+            </a:r>
+          </a:p>
+          <a:p>
+            <a:pPr>
+              <a:buNone/>
+            </a:pPr>
+            <a:r>
+              <a:rPr lang="en-US" dirty="0"/>
+              <a:t>Example inside a component:</a:t>
+            </a:r>
+          </a:p>
+          <a:p>
+            <a:pPr rtl="0">
+              <a:buNone/>
+            </a:pPr>
+            <a:r>
+              <a:rPr lang="en-US" dirty="0">
+                <a:latin typeface="Courier New" panose="02070309020205020404" pitchFamily="49" charset="0"/>
+              </a:rPr>
+              <a:t>const [</a:t>
+            </a:r>
+            <a:r>
+              <a:rPr lang="en-US" dirty="0" err="1">
+                <a:latin typeface="Courier New" panose="02070309020205020404" pitchFamily="49" charset="0"/>
+              </a:rPr>
+              <a:t>isOpen</a:t>
+            </a:r>
+            <a:r>
+              <a:rPr lang="en-US" dirty="0">
+                <a:latin typeface="Courier New" panose="02070309020205020404" pitchFamily="49" charset="0"/>
+              </a:rPr>
+              <a:t>, </a:t>
+            </a:r>
+            <a:r>
+              <a:rPr lang="en-US" dirty="0" err="1">
+                <a:latin typeface="Courier New" panose="02070309020205020404" pitchFamily="49" charset="0"/>
+              </a:rPr>
+              <a:t>setIsOpen</a:t>
+            </a:r>
+            <a:r>
+              <a:rPr lang="en-US" dirty="0">
+                <a:latin typeface="Courier New" panose="02070309020205020404" pitchFamily="49" charset="0"/>
+              </a:rPr>
+              <a:t>] = </a:t>
+            </a:r>
+            <a:r>
+              <a:rPr lang="en-US" dirty="0" err="1">
+                <a:latin typeface="Courier New" panose="02070309020205020404" pitchFamily="49" charset="0"/>
+              </a:rPr>
+              <a:t>useState</a:t>
+            </a:r>
+            <a:r>
+              <a:rPr lang="en-US" dirty="0">
+                <a:latin typeface="Courier New" panose="02070309020205020404" pitchFamily="49" charset="0"/>
+              </a:rPr>
+              <a:t>(false);</a:t>
+            </a:r>
+            <a:br>
+              <a:rPr lang="en-US" dirty="0">
+                <a:latin typeface="Courier New" panose="02070309020205020404" pitchFamily="49" charset="0"/>
+              </a:rPr>
+            </a:br>
+            <a:br>
+              <a:rPr lang="en-US" dirty="0">
+                <a:latin typeface="Courier New" panose="02070309020205020404" pitchFamily="49" charset="0"/>
+              </a:rPr>
+            </a:br>
+            <a:r>
+              <a:rPr lang="en-US" dirty="0">
+                <a:latin typeface="Courier New" panose="02070309020205020404" pitchFamily="49" charset="0"/>
+              </a:rPr>
+              <a:t>function toggle() {</a:t>
+            </a:r>
+            <a:br>
+              <a:rPr lang="en-US" dirty="0">
+                <a:latin typeface="Courier New" panose="02070309020205020404" pitchFamily="49" charset="0"/>
+              </a:rPr>
+            </a:br>
+            <a:r>
+              <a:rPr lang="en-US" dirty="0">
+                <a:latin typeface="Courier New" panose="02070309020205020404" pitchFamily="49" charset="0"/>
+              </a:rPr>
+              <a:t>  </a:t>
+            </a:r>
+            <a:r>
+              <a:rPr lang="en-US" dirty="0" err="1">
+                <a:latin typeface="Courier New" panose="02070309020205020404" pitchFamily="49" charset="0"/>
+              </a:rPr>
+              <a:t>setIsOpen</a:t>
+            </a:r>
+            <a:r>
+              <a:rPr lang="en-US" dirty="0">
+                <a:latin typeface="Courier New" panose="02070309020205020404" pitchFamily="49" charset="0"/>
+              </a:rPr>
+              <a:t>(</a:t>
+            </a:r>
+            <a:r>
+              <a:rPr lang="en-US" dirty="0" err="1">
+                <a:latin typeface="Courier New" panose="02070309020205020404" pitchFamily="49" charset="0"/>
+              </a:rPr>
+              <a:t>prev</a:t>
+            </a:r>
+            <a:r>
+              <a:rPr lang="en-US" dirty="0">
+                <a:latin typeface="Courier New" panose="02070309020205020404" pitchFamily="49" charset="0"/>
+              </a:rPr>
+              <a:t> =&gt; !</a:t>
+            </a:r>
+            <a:r>
+              <a:rPr lang="en-US" dirty="0" err="1">
+                <a:latin typeface="Courier New" panose="02070309020205020404" pitchFamily="49" charset="0"/>
+              </a:rPr>
+              <a:t>prev</a:t>
+            </a:r>
+            <a:r>
+              <a:rPr lang="en-US" dirty="0">
+                <a:latin typeface="Courier New" panose="02070309020205020404" pitchFamily="49" charset="0"/>
+              </a:rPr>
+              <a:t>);</a:t>
+            </a:r>
+            <a:br>
+              <a:rPr lang="en-US" dirty="0">
+                <a:latin typeface="Courier New" panose="02070309020205020404" pitchFamily="49" charset="0"/>
+              </a:rPr>
+            </a:br>
+            <a:r>
+              <a:rPr lang="en-US" dirty="0">
+                <a:latin typeface="Courier New" panose="02070309020205020404" pitchFamily="49" charset="0"/>
+              </a:rPr>
+              <a:t>}</a:t>
+            </a:r>
+          </a:p>
+          <a:p>
+            <a:pPr>
+              <a:buNone/>
+            </a:pPr>
+            <a:r>
+              <a:rPr lang="en-US" dirty="0"/>
+              <a:t>If you need it in </a:t>
+            </a:r>
+            <a:r>
+              <a:rPr lang="en-US" b="1" dirty="0"/>
+              <a:t>10 components</a:t>
+            </a:r>
+            <a:r>
+              <a:rPr lang="en-US" dirty="0"/>
+              <a:t>, you repeat this code </a:t>
+            </a:r>
+            <a:r>
+              <a:rPr lang="en-US" b="1" dirty="0"/>
+              <a:t>10 times</a:t>
+            </a:r>
+            <a:r>
+              <a:rPr lang="en-US" dirty="0"/>
+              <a:t>.</a:t>
+            </a:r>
+          </a:p>
+        </p:txBody>
+      </p:sp>
+    </p:spTree>
+    <p:extLst>
+      <p:ext uri="{BB962C8B-B14F-4D97-AF65-F5344CB8AC3E}">
+        <p14:creationId xmlns:p14="http://schemas.microsoft.com/office/powerpoint/2010/main" val="3112580861"/>
+      </p:ext>
+    </p:extLst>
+  </p:cSld>
+  <p:clrMapOvr>
+    <a:masterClrMapping/>
+  </p:clrMapOvr>
+</p:sld>
+</file>
+
+<file path=ppt/slides/slide21.xml><?xml version="1.0" encoding="utf-8"?>
+<p:sld xmlns:a="http://schemas.openxmlformats.org/drawingml/2006/main" xmlns:r="http://schemas.openxmlformats.org/officeDocument/2006/relationships" xmlns:p="http://schemas.openxmlformats.org/presentationml/2006/main">
+  <p:cSld>
+    <p:spTree>
+      <p:nvGrpSpPr>
         <p:cNvPr id="1" name="">
           <a:extLst>
             <a:ext uri="{FF2B5EF4-FFF2-40B4-BE49-F238E27FC236}">
@@ -5115,7 +5699,7 @@
 </p:sld>
 </file>
 
-<file path=ppt/slides/slide21.xml><?xml version="1.0" encoding="utf-8"?>
+<file path=ppt/slides/slide22.xml><?xml version="1.0" encoding="utf-8"?>
 <p:sld xmlns:a="http://schemas.openxmlformats.org/drawingml/2006/main" xmlns:r="http://schemas.openxmlformats.org/officeDocument/2006/relationships" xmlns:p="http://schemas.openxmlformats.org/presentationml/2006/main">
   <p:cSld>
     <p:spTree>
@@ -5264,7 +5848,7 @@
 </p:sld>
 </file>
 
-<file path=ppt/slides/slide22.xml><?xml version="1.0" encoding="utf-8"?>
+<file path=ppt/slides/slide23.xml><?xml version="1.0" encoding="utf-8"?>
 <p:sld xmlns:a="http://schemas.openxmlformats.org/drawingml/2006/main" xmlns:r="http://schemas.openxmlformats.org/officeDocument/2006/relationships" xmlns:p="http://schemas.openxmlformats.org/presentationml/2006/main">
   <p:cSld>
     <p:spTree>
@@ -5337,7 +5921,7 @@
 </p:sld>
 </file>
 
-<file path=ppt/slides/slide23.xml><?xml version="1.0" encoding="utf-8"?>
+<file path=ppt/slides/slide24.xml><?xml version="1.0" encoding="utf-8"?>
 <p:sld xmlns:a="http://schemas.openxmlformats.org/drawingml/2006/main" xmlns:r="http://schemas.openxmlformats.org/officeDocument/2006/relationships" xmlns:p="http://schemas.openxmlformats.org/presentationml/2006/main">
   <p:cSld>
     <p:spTree>
@@ -5507,7 +6091,7 @@
 </p:sld>
 </file>
 
-<file path=ppt/slides/slide24.xml><?xml version="1.0" encoding="utf-8"?>
+<file path=ppt/slides/slide25.xml><?xml version="1.0" encoding="utf-8"?>
 <p:sld xmlns:a="http://schemas.openxmlformats.org/drawingml/2006/main" xmlns:r="http://schemas.openxmlformats.org/officeDocument/2006/relationships" xmlns:p="http://schemas.openxmlformats.org/presentationml/2006/main">
   <p:cSld>
     <p:spTree>
@@ -5580,7 +6164,7 @@
 </p:sld>
 </file>
 
-<file path=ppt/slides/slide25.xml><?xml version="1.0" encoding="utf-8"?>
+<file path=ppt/slides/slide26.xml><?xml version="1.0" encoding="utf-8"?>
 <p:sld xmlns:a="http://schemas.openxmlformats.org/drawingml/2006/main" xmlns:r="http://schemas.openxmlformats.org/officeDocument/2006/relationships" xmlns:p="http://schemas.openxmlformats.org/presentationml/2006/main">
   <p:cSld>
     <p:spTree>
@@ -5699,7 +6283,7 @@
 </p:sld>
 </file>
 
-<file path=ppt/slides/slide26.xml><?xml version="1.0" encoding="utf-8"?>
+<file path=ppt/slides/slide27.xml><?xml version="1.0" encoding="utf-8"?>
 <p:sld xmlns:a="http://schemas.openxmlformats.org/drawingml/2006/main" xmlns:r="http://schemas.openxmlformats.org/officeDocument/2006/relationships" xmlns:p="http://schemas.openxmlformats.org/presentationml/2006/main">
   <p:cSld>
     <p:spTree>
@@ -5870,7 +6454,7 @@
 </p:sld>
 </file>
 
-<file path=ppt/slides/slide27.xml><?xml version="1.0" encoding="utf-8"?>
+<file path=ppt/slides/slide28.xml><?xml version="1.0" encoding="utf-8"?>
 <p:sld xmlns:a="http://schemas.openxmlformats.org/drawingml/2006/main" xmlns:r="http://schemas.openxmlformats.org/officeDocument/2006/relationships" xmlns:p="http://schemas.openxmlformats.org/presentationml/2006/main">
   <p:cSld>
     <p:spTree>
@@ -5943,7 +6527,7 @@
 </p:sld>
 </file>
 
-<file path=ppt/slides/slide28.xml><?xml version="1.0" encoding="utf-8"?>
+<file path=ppt/slides/slide29.xml><?xml version="1.0" encoding="utf-8"?>
 <p:sld xmlns:a="http://schemas.openxmlformats.org/drawingml/2006/main" xmlns:r="http://schemas.openxmlformats.org/officeDocument/2006/relationships" xmlns:p="http://schemas.openxmlformats.org/presentationml/2006/main">
   <p:cSld>
     <p:spTree>
@@ -6038,7 +6622,129 @@
 </p:sld>
 </file>
 
-<file path=ppt/slides/slide29.xml><?xml version="1.0" encoding="utf-8"?>
+<file path=ppt/slides/slide3.xml><?xml version="1.0" encoding="utf-8"?>
+<p:sld xmlns:a="http://schemas.openxmlformats.org/drawingml/2006/main" xmlns:r="http://schemas.openxmlformats.org/officeDocument/2006/relationships" xmlns:p="http://schemas.openxmlformats.org/presentationml/2006/main">
+  <p:cSld>
+    <p:spTree>
+      <p:nvGrpSpPr>
+        <p:cNvPr id="1" name=""/>
+        <p:cNvGrpSpPr/>
+        <p:nvPr/>
+      </p:nvGrpSpPr>
+      <p:grpSpPr>
+        <a:xfrm>
+          <a:off x="0" y="0"/>
+          <a:ext cx="0" cy="0"/>
+          <a:chOff x="0" y="0"/>
+          <a:chExt cx="0" cy="0"/>
+        </a:xfrm>
+      </p:grpSpPr>
+      <p:sp>
+        <p:nvSpPr>
+          <p:cNvPr id="2" name="Title 1">
+            <a:extLst>
+              <a:ext uri="{FF2B5EF4-FFF2-40B4-BE49-F238E27FC236}">
+                <a16:creationId xmlns:a16="http://schemas.microsoft.com/office/drawing/2014/main" id="{0866C05A-AE25-1768-8A9B-9E1C61225334}"/>
+              </a:ext>
+            </a:extLst>
+          </p:cNvPr>
+          <p:cNvSpPr>
+            <a:spLocks noGrp="1"/>
+          </p:cNvSpPr>
+          <p:nvPr>
+            <p:ph type="title"/>
+          </p:nvPr>
+        </p:nvSpPr>
+        <p:spPr/>
+        <p:txBody>
+          <a:bodyPr/>
+          <a:lstStyle/>
+          <a:p>
+            <a:r>
+              <a:rPr lang="en-US" dirty="0"/>
+              <a:t>Agenda</a:t>
+            </a:r>
+          </a:p>
+        </p:txBody>
+      </p:sp>
+      <p:sp>
+        <p:nvSpPr>
+          <p:cNvPr id="3" name="Content Placeholder 2">
+            <a:extLst>
+              <a:ext uri="{FF2B5EF4-FFF2-40B4-BE49-F238E27FC236}">
+                <a16:creationId xmlns:a16="http://schemas.microsoft.com/office/drawing/2014/main" id="{915481B4-3432-EE69-114F-1E97A4260877}"/>
+              </a:ext>
+            </a:extLst>
+          </p:cNvPr>
+          <p:cNvSpPr>
+            <a:spLocks noGrp="1"/>
+          </p:cNvSpPr>
+          <p:nvPr>
+            <p:ph idx="1"/>
+          </p:nvPr>
+        </p:nvSpPr>
+        <p:spPr/>
+        <p:txBody>
+          <a:bodyPr/>
+          <a:lstStyle/>
+          <a:p>
+            <a:r>
+              <a:rPr lang="en-US" dirty="0"/>
+              <a:t>Review: Functional components and state</a:t>
+            </a:r>
+          </a:p>
+          <a:p>
+            <a:r>
+              <a:rPr lang="en-US" dirty="0"/>
+              <a:t>Why hooks exist</a:t>
+            </a:r>
+          </a:p>
+          <a:p>
+            <a:r>
+              <a:rPr lang="en-US" dirty="0"/>
+              <a:t>Rules of Hooks</a:t>
+            </a:r>
+          </a:p>
+          <a:p>
+            <a:r>
+              <a:rPr lang="en-US" dirty="0"/>
+              <a:t>How React tracks hook calls</a:t>
+            </a:r>
+          </a:p>
+          <a:p>
+            <a:r>
+              <a:rPr lang="en-US" dirty="0"/>
+              <a:t>Building a custom hook</a:t>
+            </a:r>
+          </a:p>
+          <a:p>
+            <a:r>
+              <a:rPr lang="en-US" dirty="0"/>
+              <a:t>Applying a custom hook in our project</a:t>
+            </a:r>
+          </a:p>
+          <a:p>
+            <a:r>
+              <a:rPr lang="en-US" dirty="0"/>
+              <a:t>Exit ticket</a:t>
+            </a:r>
+          </a:p>
+        </p:txBody>
+      </p:sp>
+    </p:spTree>
+    <p:extLst>
+      <p:ext uri="{BB962C8B-B14F-4D97-AF65-F5344CB8AC3E}">
+        <p14:creationId xmlns:p14="http://schemas.microsoft.com/office/powerpoint/2010/main" val="1231324705"/>
+      </p:ext>
+    </p:extLst>
+  </p:cSld>
+  <p:clrMapOvr>
+    <a:masterClrMapping/>
+  </p:clrMapOvr>
+</p:sld>
+</file>
+
+<file path=ppt/slides/slide30.xml><?xml version="1.0" encoding="utf-8"?>
 <p:sld xmlns:a="http://schemas.openxmlformats.org/drawingml/2006/main" xmlns:r="http://schemas.openxmlformats.org/officeDocument/2006/relationships" xmlns:p="http://schemas.openxmlformats.org/presentationml/2006/main">
   <p:cSld>
     <p:spTree>
@@ -6111,129 +6817,7 @@
 </p:sld>
 </file>
 
-<file path=ppt/slides/slide3.xml><?xml version="1.0" encoding="utf-8"?>
-<p:sld xmlns:a="http://schemas.openxmlformats.org/drawingml/2006/main" xmlns:r="http://schemas.openxmlformats.org/officeDocument/2006/relationships" xmlns:p="http://schemas.openxmlformats.org/presentationml/2006/main">
-  <p:cSld>
-    <p:spTree>
-      <p:nvGrpSpPr>
-        <p:cNvPr id="1" name=""/>
-        <p:cNvGrpSpPr/>
-        <p:nvPr/>
-      </p:nvGrpSpPr>
-      <p:grpSpPr>
-        <a:xfrm>
-          <a:off x="0" y="0"/>
-          <a:ext cx="0" cy="0"/>
-          <a:chOff x="0" y="0"/>
-          <a:chExt cx="0" cy="0"/>
-        </a:xfrm>
-      </p:grpSpPr>
-      <p:sp>
-        <p:nvSpPr>
-          <p:cNvPr id="2" name="Title 1">
-            <a:extLst>
-              <a:ext uri="{FF2B5EF4-FFF2-40B4-BE49-F238E27FC236}">
-                <a16:creationId xmlns:a16="http://schemas.microsoft.com/office/drawing/2014/main" id="{0866C05A-AE25-1768-8A9B-9E1C61225334}"/>
-              </a:ext>
-            </a:extLst>
-          </p:cNvPr>
-          <p:cNvSpPr>
-            <a:spLocks noGrp="1"/>
-          </p:cNvSpPr>
-          <p:nvPr>
-            <p:ph type="title"/>
-          </p:nvPr>
-        </p:nvSpPr>
-        <p:spPr/>
-        <p:txBody>
-          <a:bodyPr/>
-          <a:lstStyle/>
-          <a:p>
-            <a:r>
-              <a:rPr lang="en-US" dirty="0"/>
-              <a:t>Agenda</a:t>
-            </a:r>
-          </a:p>
-        </p:txBody>
-      </p:sp>
-      <p:sp>
-        <p:nvSpPr>
-          <p:cNvPr id="3" name="Content Placeholder 2">
-            <a:extLst>
-              <a:ext uri="{FF2B5EF4-FFF2-40B4-BE49-F238E27FC236}">
-                <a16:creationId xmlns:a16="http://schemas.microsoft.com/office/drawing/2014/main" id="{915481B4-3432-EE69-114F-1E97A4260877}"/>
-              </a:ext>
-            </a:extLst>
-          </p:cNvPr>
-          <p:cNvSpPr>
-            <a:spLocks noGrp="1"/>
-          </p:cNvSpPr>
-          <p:nvPr>
-            <p:ph idx="1"/>
-          </p:nvPr>
-        </p:nvSpPr>
-        <p:spPr/>
-        <p:txBody>
-          <a:bodyPr/>
-          <a:lstStyle/>
-          <a:p>
-            <a:r>
-              <a:rPr lang="en-US" dirty="0"/>
-              <a:t>Review: Functional components and state</a:t>
-            </a:r>
-          </a:p>
-          <a:p>
-            <a:r>
-              <a:rPr lang="en-US" dirty="0"/>
-              <a:t>Why hooks exist</a:t>
-            </a:r>
-          </a:p>
-          <a:p>
-            <a:r>
-              <a:rPr lang="en-US" dirty="0"/>
-              <a:t>Rules of Hooks</a:t>
-            </a:r>
-          </a:p>
-          <a:p>
-            <a:r>
-              <a:rPr lang="en-US" dirty="0"/>
-              <a:t>How React tracks hook calls</a:t>
-            </a:r>
-          </a:p>
-          <a:p>
-            <a:r>
-              <a:rPr lang="en-US" dirty="0"/>
-              <a:t>Building a custom hook</a:t>
-            </a:r>
-          </a:p>
-          <a:p>
-            <a:r>
-              <a:rPr lang="en-US" dirty="0"/>
-              <a:t>Applying a custom hook in our project</a:t>
-            </a:r>
-          </a:p>
-          <a:p>
-            <a:r>
-              <a:rPr lang="en-US" dirty="0"/>
-              <a:t>Exit ticket</a:t>
-            </a:r>
-          </a:p>
-        </p:txBody>
-      </p:sp>
-    </p:spTree>
-    <p:extLst>
-      <p:ext uri="{BB962C8B-B14F-4D97-AF65-F5344CB8AC3E}">
-        <p14:creationId xmlns:p14="http://schemas.microsoft.com/office/powerpoint/2010/main" val="1231324705"/>
-      </p:ext>
-    </p:extLst>
-  </p:cSld>
-  <p:clrMapOvr>
-    <a:masterClrMapping/>
-  </p:clrMapOvr>
-</p:sld>
-</file>
-
-<file path=ppt/slides/slide30.xml><?xml version="1.0" encoding="utf-8"?>
+<file path=ppt/slides/slide31.xml><?xml version="1.0" encoding="utf-8"?>
 <p:sld xmlns:a="http://schemas.openxmlformats.org/drawingml/2006/main" xmlns:r="http://schemas.openxmlformats.org/officeDocument/2006/relationships" xmlns:p="http://schemas.openxmlformats.org/presentationml/2006/main">
   <p:cSld>
     <p:spTree>
@@ -6361,7 +6945,7 @@
 </p:sld>
 </file>
 
-<file path=ppt/slides/slide31.xml><?xml version="1.0" encoding="utf-8"?>
+<file path=ppt/slides/slide32.xml><?xml version="1.0" encoding="utf-8"?>
 <p:sld xmlns:a="http://schemas.openxmlformats.org/drawingml/2006/main" xmlns:r="http://schemas.openxmlformats.org/officeDocument/2006/relationships" xmlns:p="http://schemas.openxmlformats.org/presentationml/2006/main">
   <p:cSld>
     <p:spTree>
@@ -6503,7 +7087,7 @@
 </p:sld>
 </file>
 
-<file path=ppt/slides/slide32.xml><?xml version="1.0" encoding="utf-8"?>
+<file path=ppt/slides/slide33.xml><?xml version="1.0" encoding="utf-8"?>
 <p:sld xmlns:a="http://schemas.openxmlformats.org/drawingml/2006/main" xmlns:r="http://schemas.openxmlformats.org/officeDocument/2006/relationships" xmlns:p="http://schemas.openxmlformats.org/presentationml/2006/main">
   <p:cSld>
     <p:spTree>

</xml_diff>